<commit_message>
feat(division): Implement module settings to control sidebar navigation
- enabledModules setting now controls which menu items appear
- Added SF5 and SF6 as separate toggleable modules
- Removed unimplemented modules (SF2, SF10, Analytics, etc.)
- Default behavior: show all if no modules selected
- Dashboard, User Management, Audit Log, Settings always visible for admins
</commit_message>
<xml_diff>
--- a/docs/Division-Level-Access-Presentation.pptx
+++ b/docs/Division-Level-Access-Presentation.pptx
@@ -5091,8 +5091,8 @@
         </p:nvSpPr>
         <p:spPr>
           <a:xfrm>
-            <a:off x="457200" y="1280160"/>
-            <a:ext cx="8229600" cy="457200"/>
+            <a:off x="457200" y="1234440"/>
+            <a:ext cx="8229600" cy="365760"/>
           </a:xfrm>
           <a:prstGeom prst="rect">
             <a:avLst/>
@@ -5126,8 +5126,8 @@
         </p:nvSpPr>
         <p:spPr>
           <a:xfrm>
-            <a:off x="457200" y="1828800"/>
-            <a:ext cx="8229600" cy="4114800"/>
+            <a:off x="274320" y="1691640"/>
+            <a:ext cx="8595360" cy="4846320"/>
           </a:xfrm>
           <a:prstGeom prst="roundRect">
             <a:avLst/>
@@ -5137,7 +5137,7 @@
           </a:solidFill>
           <a:ln>
             <a:solidFill>
-              <a:srgbClr val="CBD5E1"/>
+              <a:srgbClr val="E2E8F0"/>
             </a:solidFill>
           </a:ln>
         </p:spPr>
@@ -5165,14 +5165,59 @@
       </p:sp>
       <p:sp>
         <p:nvSpPr>
-          <p:cNvPr id="6" name="TextBox 5"/>
+          <p:cNvPr id="6" name="Rounded Rectangle 5"/>
+          <p:cNvSpPr/>
+          <p:nvPr/>
+        </p:nvSpPr>
+        <p:spPr>
+          <a:xfrm>
+            <a:off x="457200" y="1874519"/>
+            <a:ext cx="8229600" cy="548640"/>
+          </a:xfrm>
+          <a:prstGeom prst="roundRect">
+            <a:avLst/>
+          </a:prstGeom>
+          <a:solidFill>
+            <a:srgbClr val="FFFFFF"/>
+          </a:solidFill>
+          <a:ln>
+            <a:solidFill>
+              <a:srgbClr val="E2E8F0"/>
+            </a:solidFill>
+          </a:ln>
+        </p:spPr>
+        <p:style>
+          <a:lnRef idx="1">
+            <a:schemeClr val="accent1"/>
+          </a:lnRef>
+          <a:fillRef idx="3">
+            <a:schemeClr val="accent1"/>
+          </a:fillRef>
+          <a:effectRef idx="2">
+            <a:schemeClr val="accent1"/>
+          </a:effectRef>
+          <a:fontRef idx="minor">
+            <a:schemeClr val="lt1"/>
+          </a:fontRef>
+        </p:style>
+        <p:txBody>
+          <a:bodyPr rtlCol="0" anchor="ctr"/>
+          <a:lstStyle/>
+          <a:p>
+            <a:pPr algn="ctr"/>
+          </a:p>
+        </p:txBody>
+      </p:sp>
+      <p:sp>
+        <p:nvSpPr>
+          <p:cNvPr id="7" name="TextBox 6"/>
           <p:cNvSpPr txBox="1"/>
           <p:nvPr/>
         </p:nvSpPr>
         <p:spPr>
           <a:xfrm>
-            <a:off x="640080" y="2011680"/>
-            <a:ext cx="7863840" cy="3840480"/>
+            <a:off x="640080" y="1965960"/>
+            <a:ext cx="4572000" cy="365760"/>
           </a:xfrm>
           <a:prstGeom prst="rect">
             <a:avLst/>
@@ -5180,90 +5225,1160 @@
           <a:noFill/>
         </p:spPr>
         <p:txBody>
-          <a:bodyPr wrap="square">
+          <a:bodyPr wrap="none">
             <a:spAutoFit/>
           </a:bodyPr>
           <a:lstStyle/>
           <a:p>
-            <a:br/>
             <a:pPr>
+              <a:defRPr sz="1600" b="1">
+                <a:solidFill>
+                  <a:srgbClr val="1E40AF"/>
+                </a:solidFill>
+              </a:defRPr>
+            </a:pPr>
+            <a:r>
+              <a:t>📍 Division of City Schools - Manila</a:t>
+            </a:r>
+          </a:p>
+        </p:txBody>
+      </p:sp>
+      <p:sp>
+        <p:nvSpPr>
+          <p:cNvPr id="8" name="TextBox 7"/>
+          <p:cNvSpPr txBox="1"/>
+          <p:nvPr/>
+        </p:nvSpPr>
+        <p:spPr>
+          <a:xfrm>
+            <a:off x="6400800" y="1965960"/>
+            <a:ext cx="2103120" cy="365760"/>
+          </a:xfrm>
+          <a:prstGeom prst="rect">
+            <a:avLst/>
+          </a:prstGeom>
+          <a:noFill/>
+        </p:spPr>
+        <p:txBody>
+          <a:bodyPr wrap="none">
+            <a:spAutoFit/>
+          </a:bodyPr>
+          <a:lstStyle/>
+          <a:p>
+            <a:pPr algn="r">
+              <a:defRPr sz="1400">
+                <a:solidFill>
+                  <a:srgbClr val="475569"/>
+                </a:solidFill>
+              </a:defRPr>
+            </a:pPr>
+            <a:r>
+              <a:t>👤 Superintendent</a:t>
+            </a:r>
+          </a:p>
+        </p:txBody>
+      </p:sp>
+      <p:sp>
+        <p:nvSpPr>
+          <p:cNvPr id="9" name="Rounded Rectangle 8"/>
+          <p:cNvSpPr/>
+          <p:nvPr/>
+        </p:nvSpPr>
+        <p:spPr>
+          <a:xfrm>
+            <a:off x="457200" y="2606040"/>
+            <a:ext cx="1874519" cy="1097280"/>
+          </a:xfrm>
+          <a:prstGeom prst="roundRect">
+            <a:avLst/>
+          </a:prstGeom>
+          <a:solidFill>
+            <a:srgbClr val="FFFFFF"/>
+          </a:solidFill>
+          <a:ln>
+            <a:solidFill>
+              <a:srgbClr val="E2E8F0"/>
+            </a:solidFill>
+          </a:ln>
+        </p:spPr>
+        <p:style>
+          <a:lnRef idx="1">
+            <a:schemeClr val="accent1"/>
+          </a:lnRef>
+          <a:fillRef idx="3">
+            <a:schemeClr val="accent1"/>
+          </a:fillRef>
+          <a:effectRef idx="2">
+            <a:schemeClr val="accent1"/>
+          </a:effectRef>
+          <a:fontRef idx="minor">
+            <a:schemeClr val="lt1"/>
+          </a:fontRef>
+        </p:style>
+        <p:txBody>
+          <a:bodyPr rtlCol="0" anchor="ctr"/>
+          <a:lstStyle/>
+          <a:p>
+            <a:pPr algn="ctr"/>
+          </a:p>
+        </p:txBody>
+      </p:sp>
+      <p:sp>
+        <p:nvSpPr>
+          <p:cNvPr id="10" name="TextBox 9"/>
+          <p:cNvSpPr txBox="1"/>
+          <p:nvPr/>
+        </p:nvSpPr>
+        <p:spPr>
+          <a:xfrm>
+            <a:off x="457200" y="2743200"/>
+            <a:ext cx="1874519" cy="548640"/>
+          </a:xfrm>
+          <a:prstGeom prst="rect">
+            <a:avLst/>
+          </a:prstGeom>
+          <a:noFill/>
+        </p:spPr>
+        <p:txBody>
+          <a:bodyPr wrap="none">
+            <a:spAutoFit/>
+          </a:bodyPr>
+          <a:lstStyle/>
+          <a:p>
+            <a:pPr algn="ctr">
+              <a:defRPr sz="2800" b="1">
+                <a:solidFill>
+                  <a:srgbClr val="1E40AF"/>
+                </a:solidFill>
+              </a:defRPr>
+            </a:pPr>
+            <a:r>
+              <a:t>🏫 42</a:t>
+            </a:r>
+          </a:p>
+        </p:txBody>
+      </p:sp>
+      <p:sp>
+        <p:nvSpPr>
+          <p:cNvPr id="11" name="TextBox 10"/>
+          <p:cNvSpPr txBox="1"/>
+          <p:nvPr/>
+        </p:nvSpPr>
+        <p:spPr>
+          <a:xfrm>
+            <a:off x="457200" y="3246120"/>
+            <a:ext cx="1874519" cy="320040"/>
+          </a:xfrm>
+          <a:prstGeom prst="rect">
+            <a:avLst/>
+          </a:prstGeom>
+          <a:noFill/>
+        </p:spPr>
+        <p:txBody>
+          <a:bodyPr wrap="none">
+            <a:spAutoFit/>
+          </a:bodyPr>
+          <a:lstStyle/>
+          <a:p>
+            <a:pPr algn="ctr">
+              <a:defRPr sz="1400">
+                <a:solidFill>
+                  <a:srgbClr val="475569"/>
+                </a:solidFill>
+              </a:defRPr>
+            </a:pPr>
+            <a:r>
+              <a:t>Schools</a:t>
+            </a:r>
+          </a:p>
+        </p:txBody>
+      </p:sp>
+      <p:sp>
+        <p:nvSpPr>
+          <p:cNvPr id="12" name="Rounded Rectangle 11"/>
+          <p:cNvSpPr/>
+          <p:nvPr/>
+        </p:nvSpPr>
+        <p:spPr>
+          <a:xfrm>
+            <a:off x="2514599" y="2606040"/>
+            <a:ext cx="1874519" cy="1097280"/>
+          </a:xfrm>
+          <a:prstGeom prst="roundRect">
+            <a:avLst/>
+          </a:prstGeom>
+          <a:solidFill>
+            <a:srgbClr val="FFFFFF"/>
+          </a:solidFill>
+          <a:ln>
+            <a:solidFill>
+              <a:srgbClr val="E2E8F0"/>
+            </a:solidFill>
+          </a:ln>
+        </p:spPr>
+        <p:style>
+          <a:lnRef idx="1">
+            <a:schemeClr val="accent1"/>
+          </a:lnRef>
+          <a:fillRef idx="3">
+            <a:schemeClr val="accent1"/>
+          </a:fillRef>
+          <a:effectRef idx="2">
+            <a:schemeClr val="accent1"/>
+          </a:effectRef>
+          <a:fontRef idx="minor">
+            <a:schemeClr val="lt1"/>
+          </a:fontRef>
+        </p:style>
+        <p:txBody>
+          <a:bodyPr rtlCol="0" anchor="ctr"/>
+          <a:lstStyle/>
+          <a:p>
+            <a:pPr algn="ctr"/>
+          </a:p>
+        </p:txBody>
+      </p:sp>
+      <p:sp>
+        <p:nvSpPr>
+          <p:cNvPr id="13" name="TextBox 12"/>
+          <p:cNvSpPr txBox="1"/>
+          <p:nvPr/>
+        </p:nvSpPr>
+        <p:spPr>
+          <a:xfrm>
+            <a:off x="2514599" y="2743200"/>
+            <a:ext cx="1874519" cy="548640"/>
+          </a:xfrm>
+          <a:prstGeom prst="rect">
+            <a:avLst/>
+          </a:prstGeom>
+          <a:noFill/>
+        </p:spPr>
+        <p:txBody>
+          <a:bodyPr wrap="none">
+            <a:spAutoFit/>
+          </a:bodyPr>
+          <a:lstStyle/>
+          <a:p>
+            <a:pPr algn="ctr">
+              <a:defRPr sz="2800" b="1">
+                <a:solidFill>
+                  <a:srgbClr val="10B981"/>
+                </a:solidFill>
+              </a:defRPr>
+            </a:pPr>
+            <a:r>
+              <a:t>👨‍🎓 25,432</a:t>
+            </a:r>
+          </a:p>
+        </p:txBody>
+      </p:sp>
+      <p:sp>
+        <p:nvSpPr>
+          <p:cNvPr id="14" name="TextBox 13"/>
+          <p:cNvSpPr txBox="1"/>
+          <p:nvPr/>
+        </p:nvSpPr>
+        <p:spPr>
+          <a:xfrm>
+            <a:off x="2514599" y="3246120"/>
+            <a:ext cx="1874519" cy="320040"/>
+          </a:xfrm>
+          <a:prstGeom prst="rect">
+            <a:avLst/>
+          </a:prstGeom>
+          <a:noFill/>
+        </p:spPr>
+        <p:txBody>
+          <a:bodyPr wrap="none">
+            <a:spAutoFit/>
+          </a:bodyPr>
+          <a:lstStyle/>
+          <a:p>
+            <a:pPr algn="ctr">
+              <a:defRPr sz="1400">
+                <a:solidFill>
+                  <a:srgbClr val="475569"/>
+                </a:solidFill>
+              </a:defRPr>
+            </a:pPr>
+            <a:r>
+              <a:t>Students</a:t>
+            </a:r>
+          </a:p>
+        </p:txBody>
+      </p:sp>
+      <p:sp>
+        <p:nvSpPr>
+          <p:cNvPr id="15" name="Rounded Rectangle 14"/>
+          <p:cNvSpPr/>
+          <p:nvPr/>
+        </p:nvSpPr>
+        <p:spPr>
+          <a:xfrm>
+            <a:off x="4571998" y="2606040"/>
+            <a:ext cx="1874519" cy="1097280"/>
+          </a:xfrm>
+          <a:prstGeom prst="roundRect">
+            <a:avLst/>
+          </a:prstGeom>
+          <a:solidFill>
+            <a:srgbClr val="FFFFFF"/>
+          </a:solidFill>
+          <a:ln>
+            <a:solidFill>
+              <a:srgbClr val="E2E8F0"/>
+            </a:solidFill>
+          </a:ln>
+        </p:spPr>
+        <p:style>
+          <a:lnRef idx="1">
+            <a:schemeClr val="accent1"/>
+          </a:lnRef>
+          <a:fillRef idx="3">
+            <a:schemeClr val="accent1"/>
+          </a:fillRef>
+          <a:effectRef idx="2">
+            <a:schemeClr val="accent1"/>
+          </a:effectRef>
+          <a:fontRef idx="minor">
+            <a:schemeClr val="lt1"/>
+          </a:fontRef>
+        </p:style>
+        <p:txBody>
+          <a:bodyPr rtlCol="0" anchor="ctr"/>
+          <a:lstStyle/>
+          <a:p>
+            <a:pPr algn="ctr"/>
+          </a:p>
+        </p:txBody>
+      </p:sp>
+      <p:sp>
+        <p:nvSpPr>
+          <p:cNvPr id="16" name="TextBox 15"/>
+          <p:cNvSpPr txBox="1"/>
+          <p:nvPr/>
+        </p:nvSpPr>
+        <p:spPr>
+          <a:xfrm>
+            <a:off x="4571998" y="2743200"/>
+            <a:ext cx="1874519" cy="548640"/>
+          </a:xfrm>
+          <a:prstGeom prst="rect">
+            <a:avLst/>
+          </a:prstGeom>
+          <a:noFill/>
+        </p:spPr>
+        <p:txBody>
+          <a:bodyPr wrap="none">
+            <a:spAutoFit/>
+          </a:bodyPr>
+          <a:lstStyle/>
+          <a:p>
+            <a:pPr algn="ctr">
+              <a:defRPr sz="2800" b="1">
+                <a:solidFill>
+                  <a:srgbClr val="8B5CF6"/>
+                </a:solidFill>
+              </a:defRPr>
+            </a:pPr>
+            <a:r>
+              <a:t>👨‍🏫 1,245</a:t>
+            </a:r>
+          </a:p>
+        </p:txBody>
+      </p:sp>
+      <p:sp>
+        <p:nvSpPr>
+          <p:cNvPr id="17" name="TextBox 16"/>
+          <p:cNvSpPr txBox="1"/>
+          <p:nvPr/>
+        </p:nvSpPr>
+        <p:spPr>
+          <a:xfrm>
+            <a:off x="4571998" y="3246120"/>
+            <a:ext cx="1874519" cy="320040"/>
+          </a:xfrm>
+          <a:prstGeom prst="rect">
+            <a:avLst/>
+          </a:prstGeom>
+          <a:noFill/>
+        </p:spPr>
+        <p:txBody>
+          <a:bodyPr wrap="none">
+            <a:spAutoFit/>
+          </a:bodyPr>
+          <a:lstStyle/>
+          <a:p>
+            <a:pPr algn="ctr">
+              <a:defRPr sz="1400">
+                <a:solidFill>
+                  <a:srgbClr val="475569"/>
+                </a:solidFill>
+              </a:defRPr>
+            </a:pPr>
+            <a:r>
+              <a:t>Teachers</a:t>
+            </a:r>
+          </a:p>
+        </p:txBody>
+      </p:sp>
+      <p:sp>
+        <p:nvSpPr>
+          <p:cNvPr id="18" name="Rounded Rectangle 17"/>
+          <p:cNvSpPr/>
+          <p:nvPr/>
+        </p:nvSpPr>
+        <p:spPr>
+          <a:xfrm>
+            <a:off x="6629397" y="2606040"/>
+            <a:ext cx="1874519" cy="1097280"/>
+          </a:xfrm>
+          <a:prstGeom prst="roundRect">
+            <a:avLst/>
+          </a:prstGeom>
+          <a:solidFill>
+            <a:srgbClr val="FFFFFF"/>
+          </a:solidFill>
+          <a:ln>
+            <a:solidFill>
+              <a:srgbClr val="E2E8F0"/>
+            </a:solidFill>
+          </a:ln>
+        </p:spPr>
+        <p:style>
+          <a:lnRef idx="1">
+            <a:schemeClr val="accent1"/>
+          </a:lnRef>
+          <a:fillRef idx="3">
+            <a:schemeClr val="accent1"/>
+          </a:fillRef>
+          <a:effectRef idx="2">
+            <a:schemeClr val="accent1"/>
+          </a:effectRef>
+          <a:fontRef idx="minor">
+            <a:schemeClr val="lt1"/>
+          </a:fontRef>
+        </p:style>
+        <p:txBody>
+          <a:bodyPr rtlCol="0" anchor="ctr"/>
+          <a:lstStyle/>
+          <a:p>
+            <a:pPr algn="ctr"/>
+          </a:p>
+        </p:txBody>
+      </p:sp>
+      <p:sp>
+        <p:nvSpPr>
+          <p:cNvPr id="19" name="TextBox 18"/>
+          <p:cNvSpPr txBox="1"/>
+          <p:nvPr/>
+        </p:nvSpPr>
+        <p:spPr>
+          <a:xfrm>
+            <a:off x="6629397" y="2743200"/>
+            <a:ext cx="1874519" cy="548640"/>
+          </a:xfrm>
+          <a:prstGeom prst="rect">
+            <a:avLst/>
+          </a:prstGeom>
+          <a:noFill/>
+        </p:spPr>
+        <p:txBody>
+          <a:bodyPr wrap="none">
+            <a:spAutoFit/>
+          </a:bodyPr>
+          <a:lstStyle/>
+          <a:p>
+            <a:pPr algn="ctr">
+              <a:defRPr sz="2800" b="1">
+                <a:solidFill>
+                  <a:srgbClr val="F59E0B"/>
+                </a:solidFill>
+              </a:defRPr>
+            </a:pPr>
+            <a:r>
+              <a:t>📈 +3.2%</a:t>
+            </a:r>
+          </a:p>
+        </p:txBody>
+      </p:sp>
+      <p:sp>
+        <p:nvSpPr>
+          <p:cNvPr id="20" name="TextBox 19"/>
+          <p:cNvSpPr txBox="1"/>
+          <p:nvPr/>
+        </p:nvSpPr>
+        <p:spPr>
+          <a:xfrm>
+            <a:off x="6629397" y="3246120"/>
+            <a:ext cx="1874519" cy="320040"/>
+          </a:xfrm>
+          <a:prstGeom prst="rect">
+            <a:avLst/>
+          </a:prstGeom>
+          <a:noFill/>
+        </p:spPr>
+        <p:txBody>
+          <a:bodyPr wrap="none">
+            <a:spAutoFit/>
+          </a:bodyPr>
+          <a:lstStyle/>
+          <a:p>
+            <a:pPr algn="ctr">
+              <a:defRPr sz="1400">
+                <a:solidFill>
+                  <a:srgbClr val="475569"/>
+                </a:solidFill>
+              </a:defRPr>
+            </a:pPr>
+            <a:r>
+              <a:t>Growth</a:t>
+            </a:r>
+          </a:p>
+        </p:txBody>
+      </p:sp>
+      <p:sp>
+        <p:nvSpPr>
+          <p:cNvPr id="21" name="Rounded Rectangle 20"/>
+          <p:cNvSpPr/>
+          <p:nvPr/>
+        </p:nvSpPr>
+        <p:spPr>
+          <a:xfrm>
+            <a:off x="457200" y="3886200"/>
+            <a:ext cx="8229600" cy="457200"/>
+          </a:xfrm>
+          <a:prstGeom prst="roundRect">
+            <a:avLst/>
+          </a:prstGeom>
+          <a:solidFill>
+            <a:srgbClr val="FFFFFF"/>
+          </a:solidFill>
+          <a:ln>
+            <a:solidFill>
+              <a:srgbClr val="E2E8F0"/>
+            </a:solidFill>
+          </a:ln>
+        </p:spPr>
+        <p:style>
+          <a:lnRef idx="1">
+            <a:schemeClr val="accent1"/>
+          </a:lnRef>
+          <a:fillRef idx="3">
+            <a:schemeClr val="accent1"/>
+          </a:fillRef>
+          <a:effectRef idx="2">
+            <a:schemeClr val="accent1"/>
+          </a:effectRef>
+          <a:fontRef idx="minor">
+            <a:schemeClr val="lt1"/>
+          </a:fontRef>
+        </p:style>
+        <p:txBody>
+          <a:bodyPr rtlCol="0" anchor="ctr"/>
+          <a:lstStyle/>
+          <a:p>
+            <a:pPr algn="ctr"/>
+          </a:p>
+        </p:txBody>
+      </p:sp>
+      <p:sp>
+        <p:nvSpPr>
+          <p:cNvPr id="22" name="TextBox 21"/>
+          <p:cNvSpPr txBox="1"/>
+          <p:nvPr/>
+        </p:nvSpPr>
+        <p:spPr>
+          <a:xfrm>
+            <a:off x="640080" y="3977640"/>
+            <a:ext cx="3657600" cy="320040"/>
+          </a:xfrm>
+          <a:prstGeom prst="rect">
+            <a:avLst/>
+          </a:prstGeom>
+          <a:noFill/>
+        </p:spPr>
+        <p:txBody>
+          <a:bodyPr wrap="none">
+            <a:spAutoFit/>
+          </a:bodyPr>
+          <a:lstStyle/>
+          <a:p>
+            <a:pPr>
+              <a:defRPr sz="1600" b="1">
+                <a:solidFill>
+                  <a:srgbClr val="1E40AF"/>
+                </a:solidFill>
+              </a:defRPr>
+            </a:pPr>
+            <a:r>
+              <a:t>🏫 Schools Overview</a:t>
+            </a:r>
+          </a:p>
+        </p:txBody>
+      </p:sp>
+      <p:sp>
+        <p:nvSpPr>
+          <p:cNvPr id="23" name="TextBox 22"/>
+          <p:cNvSpPr txBox="1"/>
+          <p:nvPr/>
+        </p:nvSpPr>
+        <p:spPr>
+          <a:xfrm>
+            <a:off x="6858000" y="3977640"/>
+            <a:ext cx="1645920" cy="320040"/>
+          </a:xfrm>
+          <a:prstGeom prst="rect">
+            <a:avLst/>
+          </a:prstGeom>
+          <a:noFill/>
+        </p:spPr>
+        <p:txBody>
+          <a:bodyPr wrap="none">
+            <a:spAutoFit/>
+          </a:bodyPr>
+          <a:lstStyle/>
+          <a:p>
+            <a:pPr algn="r">
+              <a:defRPr sz="1200">
+                <a:solidFill>
+                  <a:srgbClr val="3B82F6"/>
+                </a:solidFill>
+              </a:defRPr>
+            </a:pPr>
+            <a:r>
+              <a:t>View All →</a:t>
+            </a:r>
+          </a:p>
+        </p:txBody>
+      </p:sp>
+      <p:sp>
+        <p:nvSpPr>
+          <p:cNvPr id="24" name="Rounded Rectangle 23"/>
+          <p:cNvSpPr/>
+          <p:nvPr/>
+        </p:nvSpPr>
+        <p:spPr>
+          <a:xfrm>
+            <a:off x="457200" y="4480560"/>
+            <a:ext cx="1874519" cy="822960"/>
+          </a:xfrm>
+          <a:prstGeom prst="roundRect">
+            <a:avLst/>
+          </a:prstGeom>
+          <a:solidFill>
+            <a:srgbClr val="FFFFFF"/>
+          </a:solidFill>
+          <a:ln>
+            <a:solidFill>
+              <a:srgbClr val="E2E8F0"/>
+            </a:solidFill>
+          </a:ln>
+        </p:spPr>
+        <p:style>
+          <a:lnRef idx="1">
+            <a:schemeClr val="accent1"/>
+          </a:lnRef>
+          <a:fillRef idx="3">
+            <a:schemeClr val="accent1"/>
+          </a:fillRef>
+          <a:effectRef idx="2">
+            <a:schemeClr val="accent1"/>
+          </a:effectRef>
+          <a:fontRef idx="minor">
+            <a:schemeClr val="lt1"/>
+          </a:fontRef>
+        </p:style>
+        <p:txBody>
+          <a:bodyPr rtlCol="0" anchor="ctr"/>
+          <a:lstStyle/>
+          <a:p>
+            <a:pPr algn="ctr"/>
+          </a:p>
+        </p:txBody>
+      </p:sp>
+      <p:sp>
+        <p:nvSpPr>
+          <p:cNvPr id="25" name="TextBox 24"/>
+          <p:cNvSpPr txBox="1"/>
+          <p:nvPr/>
+        </p:nvSpPr>
+        <p:spPr>
+          <a:xfrm>
+            <a:off x="457200" y="4572000"/>
+            <a:ext cx="1874519" cy="320040"/>
+          </a:xfrm>
+          <a:prstGeom prst="rect">
+            <a:avLst/>
+          </a:prstGeom>
+          <a:noFill/>
+        </p:spPr>
+        <p:txBody>
+          <a:bodyPr wrap="none">
+            <a:spAutoFit/>
+          </a:bodyPr>
+          <a:lstStyle/>
+          <a:p>
+            <a:pPr algn="ctr">
+              <a:defRPr sz="1200" b="1">
+                <a:solidFill>
+                  <a:srgbClr val="475569"/>
+                </a:solidFill>
+              </a:defRPr>
+            </a:pPr>
+            <a:r>
+              <a:t>🏫 Rizal Elem.</a:t>
+            </a:r>
+          </a:p>
+        </p:txBody>
+      </p:sp>
+      <p:sp>
+        <p:nvSpPr>
+          <p:cNvPr id="26" name="TextBox 25"/>
+          <p:cNvSpPr txBox="1"/>
+          <p:nvPr/>
+        </p:nvSpPr>
+        <p:spPr>
+          <a:xfrm>
+            <a:off x="457200" y="4892040"/>
+            <a:ext cx="1874519" cy="320040"/>
+          </a:xfrm>
+          <a:prstGeom prst="rect">
+            <a:avLst/>
+          </a:prstGeom>
+          <a:noFill/>
+        </p:spPr>
+        <p:txBody>
+          <a:bodyPr wrap="none">
+            <a:spAutoFit/>
+          </a:bodyPr>
+          <a:lstStyle/>
+          <a:p>
+            <a:pPr algn="ctr">
               <a:defRPr sz="1100">
                 <a:solidFill>
+                  <a:srgbClr val="3B82F6"/>
+                </a:solidFill>
+              </a:defRPr>
+            </a:pPr>
+            <a:r>
+              <a:t>👨‍🎓 523 students</a:t>
+            </a:r>
+          </a:p>
+        </p:txBody>
+      </p:sp>
+      <p:sp>
+        <p:nvSpPr>
+          <p:cNvPr id="27" name="Rounded Rectangle 26"/>
+          <p:cNvSpPr/>
+          <p:nvPr/>
+        </p:nvSpPr>
+        <p:spPr>
+          <a:xfrm>
+            <a:off x="2514599" y="4480560"/>
+            <a:ext cx="1874519" cy="822960"/>
+          </a:xfrm>
+          <a:prstGeom prst="roundRect">
+            <a:avLst/>
+          </a:prstGeom>
+          <a:solidFill>
+            <a:srgbClr val="FFFFFF"/>
+          </a:solidFill>
+          <a:ln>
+            <a:solidFill>
+              <a:srgbClr val="E2E8F0"/>
+            </a:solidFill>
+          </a:ln>
+        </p:spPr>
+        <p:style>
+          <a:lnRef idx="1">
+            <a:schemeClr val="accent1"/>
+          </a:lnRef>
+          <a:fillRef idx="3">
+            <a:schemeClr val="accent1"/>
+          </a:fillRef>
+          <a:effectRef idx="2">
+            <a:schemeClr val="accent1"/>
+          </a:effectRef>
+          <a:fontRef idx="minor">
+            <a:schemeClr val="lt1"/>
+          </a:fontRef>
+        </p:style>
+        <p:txBody>
+          <a:bodyPr rtlCol="0" anchor="ctr"/>
+          <a:lstStyle/>
+          <a:p>
+            <a:pPr algn="ctr"/>
+          </a:p>
+        </p:txBody>
+      </p:sp>
+      <p:sp>
+        <p:nvSpPr>
+          <p:cNvPr id="28" name="TextBox 27"/>
+          <p:cNvSpPr txBox="1"/>
+          <p:nvPr/>
+        </p:nvSpPr>
+        <p:spPr>
+          <a:xfrm>
+            <a:off x="2514599" y="4572000"/>
+            <a:ext cx="1874519" cy="320040"/>
+          </a:xfrm>
+          <a:prstGeom prst="rect">
+            <a:avLst/>
+          </a:prstGeom>
+          <a:noFill/>
+        </p:spPr>
+        <p:txBody>
+          <a:bodyPr wrap="none">
+            <a:spAutoFit/>
+          </a:bodyPr>
+          <a:lstStyle/>
+          <a:p>
+            <a:pPr algn="ctr">
+              <a:defRPr sz="1200" b="1">
+                <a:solidFill>
                   <a:srgbClr val="475569"/>
                 </a:solidFill>
-                <a:latin typeface="Consolas"/>
-              </a:defRPr>
-            </a:pPr>
-            <a:r>
-              <a:t>┌──────────────────────────────────────────────────────────────┐</a:t>
-            </a:r>
-            <a:br/>
-            <a:r>
-              <a:t>│  📍 Division of City Schools - Manila       👤 Superintendent │</a:t>
-            </a:r>
-            <a:br/>
-            <a:r>
-              <a:t>├───────────────────────────────────────────────────────────────┤</a:t>
-            </a:r>
-            <a:br/>
-            <a:r>
-              <a:t>│                                                               │</a:t>
-            </a:r>
-            <a:br/>
-            <a:r>
-              <a:t>│  ┌─────────┐  ┌─────────┐  ┌─────────┐  ┌─────────┐         │</a:t>
-            </a:r>
-            <a:br/>
-            <a:r>
-              <a:t>│  │ 🏫 42   │  │ 👨‍🎓 25,432│  │ 👨‍🏫 1,245│  │ 📈 +3.2% │         │</a:t>
-            </a:r>
-            <a:br/>
-            <a:r>
-              <a:t>│  │ Schools │  │ Students │  │ Teachers│  │ Growth  │         │</a:t>
-            </a:r>
-            <a:br/>
-            <a:r>
-              <a:t>│  └─────────┘  └─────────┘  └─────────┘  └─────────┘         │</a:t>
-            </a:r>
-            <a:br/>
-            <a:r>
-              <a:t>│                                                               │</a:t>
-            </a:r>
-            <a:br/>
-            <a:r>
-              <a:t>│  ┌─────────────────────────────────────────────────────────┐ │</a:t>
-            </a:r>
-            <a:br/>
-            <a:r>
-              <a:t>│  │ 🏫 Schools Overview                      [View All →]   │ │</a:t>
-            </a:r>
-            <a:br/>
-            <a:r>
-              <a:t>│  │ ┌────────┐ ┌────────┐ ┌────────┐ ┌────────┐            │ │</a:t>
-            </a:r>
-            <a:br/>
-            <a:r>
-              <a:t>│  │ │School 1│ │School 2│ │School 3│ │School 4│   ...      │ │</a:t>
-            </a:r>
-            <a:br/>
-            <a:r>
-              <a:t>│  │ │ 523    │ │ 412    │ │ 687    │ │ 345    │            │ │</a:t>
-            </a:r>
-            <a:br/>
-            <a:r>
-              <a:t>│  │ └────────┘ └────────┘ └────────┘ └────────┘            │ │</a:t>
-            </a:r>
-            <a:br/>
-            <a:r>
-              <a:t>│  └─────────────────────────────────────────────────────────┘ │</a:t>
-            </a:r>
-            <a:br/>
-            <a:r>
-              <a:t>└──────────────────────────────────────────────────────────────┘</a:t>
-            </a:r>
-            <a:br/>
-            <a:r>
-              <a:t>        </a:t>
+              </a:defRPr>
+            </a:pPr>
+            <a:r>
+              <a:t>🏫 Bonifacio ES</a:t>
+            </a:r>
+          </a:p>
+        </p:txBody>
+      </p:sp>
+      <p:sp>
+        <p:nvSpPr>
+          <p:cNvPr id="29" name="TextBox 28"/>
+          <p:cNvSpPr txBox="1"/>
+          <p:nvPr/>
+        </p:nvSpPr>
+        <p:spPr>
+          <a:xfrm>
+            <a:off x="2514599" y="4892040"/>
+            <a:ext cx="1874519" cy="320040"/>
+          </a:xfrm>
+          <a:prstGeom prst="rect">
+            <a:avLst/>
+          </a:prstGeom>
+          <a:noFill/>
+        </p:spPr>
+        <p:txBody>
+          <a:bodyPr wrap="none">
+            <a:spAutoFit/>
+          </a:bodyPr>
+          <a:lstStyle/>
+          <a:p>
+            <a:pPr algn="ctr">
+              <a:defRPr sz="1100">
+                <a:solidFill>
+                  <a:srgbClr val="3B82F6"/>
+                </a:solidFill>
+              </a:defRPr>
+            </a:pPr>
+            <a:r>
+              <a:t>👨‍🎓 412 students</a:t>
+            </a:r>
+          </a:p>
+        </p:txBody>
+      </p:sp>
+      <p:sp>
+        <p:nvSpPr>
+          <p:cNvPr id="30" name="Rounded Rectangle 29"/>
+          <p:cNvSpPr/>
+          <p:nvPr/>
+        </p:nvSpPr>
+        <p:spPr>
+          <a:xfrm>
+            <a:off x="4571998" y="4480560"/>
+            <a:ext cx="1874519" cy="822960"/>
+          </a:xfrm>
+          <a:prstGeom prst="roundRect">
+            <a:avLst/>
+          </a:prstGeom>
+          <a:solidFill>
+            <a:srgbClr val="FFFFFF"/>
+          </a:solidFill>
+          <a:ln>
+            <a:solidFill>
+              <a:srgbClr val="E2E8F0"/>
+            </a:solidFill>
+          </a:ln>
+        </p:spPr>
+        <p:style>
+          <a:lnRef idx="1">
+            <a:schemeClr val="accent1"/>
+          </a:lnRef>
+          <a:fillRef idx="3">
+            <a:schemeClr val="accent1"/>
+          </a:fillRef>
+          <a:effectRef idx="2">
+            <a:schemeClr val="accent1"/>
+          </a:effectRef>
+          <a:fontRef idx="minor">
+            <a:schemeClr val="lt1"/>
+          </a:fontRef>
+        </p:style>
+        <p:txBody>
+          <a:bodyPr rtlCol="0" anchor="ctr"/>
+          <a:lstStyle/>
+          <a:p>
+            <a:pPr algn="ctr"/>
+          </a:p>
+        </p:txBody>
+      </p:sp>
+      <p:sp>
+        <p:nvSpPr>
+          <p:cNvPr id="31" name="TextBox 30"/>
+          <p:cNvSpPr txBox="1"/>
+          <p:nvPr/>
+        </p:nvSpPr>
+        <p:spPr>
+          <a:xfrm>
+            <a:off x="4571998" y="4572000"/>
+            <a:ext cx="1874519" cy="320040"/>
+          </a:xfrm>
+          <a:prstGeom prst="rect">
+            <a:avLst/>
+          </a:prstGeom>
+          <a:noFill/>
+        </p:spPr>
+        <p:txBody>
+          <a:bodyPr wrap="none">
+            <a:spAutoFit/>
+          </a:bodyPr>
+          <a:lstStyle/>
+          <a:p>
+            <a:pPr algn="ctr">
+              <a:defRPr sz="1200" b="1">
+                <a:solidFill>
+                  <a:srgbClr val="475569"/>
+                </a:solidFill>
+              </a:defRPr>
+            </a:pPr>
+            <a:r>
+              <a:t>🏫 Mabini Central</a:t>
+            </a:r>
+          </a:p>
+        </p:txBody>
+      </p:sp>
+      <p:sp>
+        <p:nvSpPr>
+          <p:cNvPr id="32" name="TextBox 31"/>
+          <p:cNvSpPr txBox="1"/>
+          <p:nvPr/>
+        </p:nvSpPr>
+        <p:spPr>
+          <a:xfrm>
+            <a:off x="4571998" y="4892040"/>
+            <a:ext cx="1874519" cy="320040"/>
+          </a:xfrm>
+          <a:prstGeom prst="rect">
+            <a:avLst/>
+          </a:prstGeom>
+          <a:noFill/>
+        </p:spPr>
+        <p:txBody>
+          <a:bodyPr wrap="none">
+            <a:spAutoFit/>
+          </a:bodyPr>
+          <a:lstStyle/>
+          <a:p>
+            <a:pPr algn="ctr">
+              <a:defRPr sz="1100">
+                <a:solidFill>
+                  <a:srgbClr val="3B82F6"/>
+                </a:solidFill>
+              </a:defRPr>
+            </a:pPr>
+            <a:r>
+              <a:t>👨‍🎓 687 students</a:t>
+            </a:r>
+          </a:p>
+        </p:txBody>
+      </p:sp>
+      <p:sp>
+        <p:nvSpPr>
+          <p:cNvPr id="33" name="Rounded Rectangle 32"/>
+          <p:cNvSpPr/>
+          <p:nvPr/>
+        </p:nvSpPr>
+        <p:spPr>
+          <a:xfrm>
+            <a:off x="6629397" y="4480560"/>
+            <a:ext cx="1874519" cy="822960"/>
+          </a:xfrm>
+          <a:prstGeom prst="roundRect">
+            <a:avLst/>
+          </a:prstGeom>
+          <a:solidFill>
+            <a:srgbClr val="FFFFFF"/>
+          </a:solidFill>
+          <a:ln>
+            <a:solidFill>
+              <a:srgbClr val="E2E8F0"/>
+            </a:solidFill>
+          </a:ln>
+        </p:spPr>
+        <p:style>
+          <a:lnRef idx="1">
+            <a:schemeClr val="accent1"/>
+          </a:lnRef>
+          <a:fillRef idx="3">
+            <a:schemeClr val="accent1"/>
+          </a:fillRef>
+          <a:effectRef idx="2">
+            <a:schemeClr val="accent1"/>
+          </a:effectRef>
+          <a:fontRef idx="minor">
+            <a:schemeClr val="lt1"/>
+          </a:fontRef>
+        </p:style>
+        <p:txBody>
+          <a:bodyPr rtlCol="0" anchor="ctr"/>
+          <a:lstStyle/>
+          <a:p>
+            <a:pPr algn="ctr"/>
+          </a:p>
+        </p:txBody>
+      </p:sp>
+      <p:sp>
+        <p:nvSpPr>
+          <p:cNvPr id="34" name="TextBox 33"/>
+          <p:cNvSpPr txBox="1"/>
+          <p:nvPr/>
+        </p:nvSpPr>
+        <p:spPr>
+          <a:xfrm>
+            <a:off x="6629397" y="4572000"/>
+            <a:ext cx="1874519" cy="320040"/>
+          </a:xfrm>
+          <a:prstGeom prst="rect">
+            <a:avLst/>
+          </a:prstGeom>
+          <a:noFill/>
+        </p:spPr>
+        <p:txBody>
+          <a:bodyPr wrap="none">
+            <a:spAutoFit/>
+          </a:bodyPr>
+          <a:lstStyle/>
+          <a:p>
+            <a:pPr algn="ctr">
+              <a:defRPr sz="1200" b="1">
+                <a:solidFill>
+                  <a:srgbClr val="475569"/>
+                </a:solidFill>
+              </a:defRPr>
+            </a:pPr>
+            <a:r>
+              <a:t>🏫 Aguinaldo ES</a:t>
+            </a:r>
+          </a:p>
+        </p:txBody>
+      </p:sp>
+      <p:sp>
+        <p:nvSpPr>
+          <p:cNvPr id="35" name="TextBox 34"/>
+          <p:cNvSpPr txBox="1"/>
+          <p:nvPr/>
+        </p:nvSpPr>
+        <p:spPr>
+          <a:xfrm>
+            <a:off x="6629397" y="4892040"/>
+            <a:ext cx="1874519" cy="320040"/>
+          </a:xfrm>
+          <a:prstGeom prst="rect">
+            <a:avLst/>
+          </a:prstGeom>
+          <a:noFill/>
+        </p:spPr>
+        <p:txBody>
+          <a:bodyPr wrap="none">
+            <a:spAutoFit/>
+          </a:bodyPr>
+          <a:lstStyle/>
+          <a:p>
+            <a:pPr algn="ctr">
+              <a:defRPr sz="1100">
+                <a:solidFill>
+                  <a:srgbClr val="3B82F6"/>
+                </a:solidFill>
+              </a:defRPr>
+            </a:pPr>
+            <a:r>
+              <a:t>👨‍🎓 345 students</a:t>
+            </a:r>
+          </a:p>
+        </p:txBody>
+      </p:sp>
+      <p:sp>
+        <p:nvSpPr>
+          <p:cNvPr id="36" name="TextBox 35"/>
+          <p:cNvSpPr txBox="1"/>
+          <p:nvPr/>
+        </p:nvSpPr>
+        <p:spPr>
+          <a:xfrm>
+            <a:off x="7955279" y="4754880"/>
+            <a:ext cx="548640" cy="320040"/>
+          </a:xfrm>
+          <a:prstGeom prst="rect">
+            <a:avLst/>
+          </a:prstGeom>
+          <a:noFill/>
+        </p:spPr>
+        <p:txBody>
+          <a:bodyPr wrap="none">
+            <a:spAutoFit/>
+          </a:bodyPr>
+          <a:lstStyle/>
+          <a:p>
+            <a:pPr>
+              <a:defRPr sz="1800" b="1">
+                <a:solidFill>
+                  <a:srgbClr val="475569"/>
+                </a:solidFill>
+              </a:defRPr>
+            </a:pPr>
+            <a:r>
+              <a:t>...</a:t>
+            </a:r>
+          </a:p>
+        </p:txBody>
+      </p:sp>
+      <p:sp>
+        <p:nvSpPr>
+          <p:cNvPr id="37" name="TextBox 36"/>
+          <p:cNvSpPr txBox="1"/>
+          <p:nvPr/>
+        </p:nvSpPr>
+        <p:spPr>
+          <a:xfrm>
+            <a:off x="457200" y="6309360"/>
+            <a:ext cx="8229600" cy="274320"/>
+          </a:xfrm>
+          <a:prstGeom prst="rect">
+            <a:avLst/>
+          </a:prstGeom>
+          <a:noFill/>
+        </p:spPr>
+        <p:txBody>
+          <a:bodyPr wrap="none">
+            <a:spAutoFit/>
+          </a:bodyPr>
+          <a:lstStyle/>
+          <a:p>
+            <a:pPr algn="ctr">
+              <a:defRPr sz="1100" i="1">
+                <a:solidFill>
+                  <a:srgbClr val="94A3B8"/>
+                </a:solidFill>
+              </a:defRPr>
+            </a:pPr>
+            <a:r>
+              <a:t>Real-time dashboard with server-side aggregation for optimal performance</a:t>
             </a:r>
           </a:p>
         </p:txBody>

</xml_diff>